<commit_message>
Add Gantt-view timeline slide to VP scenario comparison deck
Co-Authored-By: Claude Fable 5 <noreply@anthropic.com>
Claude-Session: https://claude.ai/code/session_01PjkGa73vYX7w9cKmbSdZpf
</commit_message>
<xml_diff>
--- a/presentations/VP_Scenario_Comparison.pptx
+++ b/presentations/VP_Scenario_Comparison.pptx
@@ -6,6 +6,7 @@
   </p:sldMasterIdLst>
   <p:sldIdLst>
     <p:sldId id="256" r:id="rId7"/>
+    <p:sldId id="257" r:id="rId8"/>
   </p:sldIdLst>
   <p:sldSz cx="12191695" cy="6858000" type="screen4x3"/>
   <p:notesSz cx="6858000" cy="9144000"/>
@@ -4652,6 +4653,152 @@
 </p:sld>
 </file>
 
+<file path=ppt/slides/slide2.xml><?xml version="1.0" encoding="utf-8"?>
+<p:sld xmlns:a="http://schemas.openxmlformats.org/drawingml/2006/main" xmlns:p="http://schemas.openxmlformats.org/presentationml/2006/main" xmlns:r="http://schemas.openxmlformats.org/officeDocument/2006/relationships">
+  <p:cSld>
+    <p:spTree>
+      <p:nvGrpSpPr>
+        <p:cNvPr id="1" name=""/>
+        <p:cNvGrpSpPr/>
+        <p:nvPr/>
+      </p:nvGrpSpPr>
+      <p:grpSpPr/>
+      <p:sp>
+        <p:nvSpPr>
+          <p:cNvPr id="2" name="Rectangle 1"/>
+          <p:cNvSpPr/>
+          <p:nvPr/>
+        </p:nvSpPr>
+        <p:spPr>
+          <a:xfrm>
+            <a:off x="0" y="0"/>
+            <a:ext cx="12191695" cy="566928"/>
+          </a:xfrm>
+          <a:prstGeom prst="rect">
+            <a:avLst/>
+          </a:prstGeom>
+          <a:solidFill>
+            <a:srgbClr val="1F3B5C"/>
+          </a:solidFill>
+          <a:ln>
+            <a:noFill/>
+          </a:ln>
+        </p:spPr>
+        <p:style>
+          <a:lnRef idx="1">
+            <a:schemeClr val="accent1"/>
+          </a:lnRef>
+          <a:fillRef idx="3">
+            <a:schemeClr val="accent1"/>
+          </a:fillRef>
+          <a:effectRef idx="2">
+            <a:schemeClr val="accent1"/>
+          </a:effectRef>
+          <a:fontRef idx="minor">
+            <a:schemeClr val="lt1"/>
+          </a:fontRef>
+        </p:style>
+        <p:txBody>
+          <a:bodyPr rtlCol="0" anchor="ctr" lIns="320040"/>
+          <a:lstStyle/>
+          <a:p>
+            <a:pPr algn="ctr"/>
+            <a:r>
+              <a:rPr sz="2200" b="1">
+                <a:solidFill>
+                  <a:srgbClr val="FFFFFF"/>
+                </a:solidFill>
+                <a:latin typeface="Calibri"/>
+              </a:rPr>
+              <a:t>Program Timeline — Gantt View: Sequential vs Parallel Execution</a:t>
+            </a:r>
+          </a:p>
+        </p:txBody>
+      </p:sp>
+      <p:pic>
+        <p:nvPicPr>
+          <p:cNvPr id="3" name="Picture 2" descr="gantt.png"/>
+          <p:cNvPicPr>
+            <a:picLocks noChangeAspect="1"/>
+          </p:cNvPicPr>
+          <p:nvPr/>
+        </p:nvPicPr>
+        <p:blipFill>
+          <a:blip r:embed="rId2"/>
+          <a:stretch>
+            <a:fillRect/>
+          </a:stretch>
+        </p:blipFill>
+        <p:spPr>
+          <a:xfrm>
+            <a:off x="0" y="603504"/>
+            <a:ext cx="12191695" cy="5624298"/>
+          </a:xfrm>
+          <a:prstGeom prst="rect">
+            <a:avLst/>
+          </a:prstGeom>
+        </p:spPr>
+      </p:pic>
+      <p:sp>
+        <p:nvSpPr>
+          <p:cNvPr id="4" name="Rectangle 3"/>
+          <p:cNvSpPr/>
+          <p:nvPr/>
+        </p:nvSpPr>
+        <p:spPr>
+          <a:xfrm>
+            <a:off x="228600" y="6291072"/>
+            <a:ext cx="11731752" cy="457200"/>
+          </a:xfrm>
+          <a:prstGeom prst="rect">
+            <a:avLst/>
+          </a:prstGeom>
+          <a:solidFill>
+            <a:srgbClr val="1F3B5C"/>
+          </a:solidFill>
+          <a:ln>
+            <a:noFill/>
+          </a:ln>
+        </p:spPr>
+        <p:style>
+          <a:lnRef idx="1">
+            <a:schemeClr val="accent1"/>
+          </a:lnRef>
+          <a:fillRef idx="3">
+            <a:schemeClr val="accent1"/>
+          </a:fillRef>
+          <a:effectRef idx="2">
+            <a:schemeClr val="accent1"/>
+          </a:effectRef>
+          <a:fontRef idx="minor">
+            <a:schemeClr val="lt1"/>
+          </a:fontRef>
+        </p:style>
+        <p:txBody>
+          <a:bodyPr rtlCol="0" anchor="ctr" lIns="137160"/>
+          <a:lstStyle/>
+          <a:p>
+            <a:pPr algn="ctr"/>
+            <a:r>
+              <a:rPr sz="1200" b="1">
+                <a:solidFill>
+                  <a:srgbClr val="FFFFFF"/>
+                </a:solidFill>
+                <a:latin typeface="Calibri"/>
+              </a:rPr>
+              <a:t>Key takeaway:  Sequential execution reaches 4-Stage 1st production ~4 months earlier (28-Jul-28 vs 27-Nov-28) and VFD 1st production ~1 week earlier (9-May-29 vs 16-May-29), avoiding the Oct-28 EC release conflict.</a:t>
+            </a:r>
+          </a:p>
+        </p:txBody>
+      </p:sp>
+    </p:spTree>
+  </p:cSld>
+  <p:clrMapOvr>
+    <a:masterClrMapping/>
+  </p:clrMapOvr>
+</p:sld>
+</file>
+
 <file path=ppt/theme/theme1.xml><?xml version="1.0" encoding="utf-8"?>
 <a:theme xmlns:a="http://schemas.openxmlformats.org/drawingml/2006/main" name="Office Theme">
   <a:themeElements>

</xml_diff>

<commit_message>
Add scenario definitions and challenges to Gantt timeline slide
Co-Authored-By: Claude Fable 5 <noreply@anthropic.com>
Claude-Session: https://claude.ai/code/session_01PjkGa73vYX7w9cKmbSdZpf
</commit_message>
<xml_diff>
--- a/presentations/VP_Scenario_Comparison.pptx
+++ b/presentations/VP_Scenario_Comparison.pptx
@@ -4732,7 +4732,7 @@
         <p:spPr>
           <a:xfrm>
             <a:off x="0" y="603504"/>
-            <a:ext cx="12191695" cy="5624298"/>
+            <a:ext cx="12191695" cy="4892682"/>
           </a:xfrm>
           <a:prstGeom prst="rect">
             <a:avLst/>
@@ -4741,52 +4741,182 @@
       </p:pic>
       <p:sp>
         <p:nvSpPr>
-          <p:cNvPr id="4" name="Rectangle 3"/>
-          <p:cNvSpPr/>
+          <p:cNvPr id="4" name="TextBox 3"/>
+          <p:cNvSpPr txBox="1"/>
           <p:nvPr/>
         </p:nvSpPr>
         <p:spPr>
           <a:xfrm>
-            <a:off x="228600" y="6291072"/>
-            <a:ext cx="11731752" cy="457200"/>
+            <a:off x="228600" y="5559552"/>
+            <a:ext cx="5806440" cy="1225296"/>
           </a:xfrm>
           <a:prstGeom prst="rect">
             <a:avLst/>
           </a:prstGeom>
           <a:solidFill>
-            <a:srgbClr val="1F3B5C"/>
+            <a:srgbClr val="FFFFFF"/>
           </a:solidFill>
-          <a:ln>
-            <a:noFill/>
+          <a:ln w="9525">
+            <a:solidFill>
+              <a:srgbClr val="2E74B5"/>
+            </a:solidFill>
           </a:ln>
         </p:spPr>
-        <p:style>
-          <a:lnRef idx="1">
-            <a:schemeClr val="accent1"/>
-          </a:lnRef>
-          <a:fillRef idx="3">
-            <a:schemeClr val="accent1"/>
-          </a:fillRef>
-          <a:effectRef idx="2">
-            <a:schemeClr val="accent1"/>
-          </a:effectRef>
-          <a:fontRef idx="minor">
-            <a:schemeClr val="lt1"/>
-          </a:fontRef>
-        </p:style>
-        <p:txBody>
-          <a:bodyPr rtlCol="0" anchor="ctr" lIns="137160"/>
-          <a:lstStyle/>
-          <a:p>
-            <a:pPr algn="ctr"/>
-            <a:r>
-              <a:rPr sz="1200" b="1">
+        <p:txBody>
+          <a:bodyPr wrap="square" tIns="36576" bIns="36576">
+            <a:spAutoFit/>
+          </a:bodyPr>
+          <a:lstStyle/>
+          <a:p>
+            <a:r>
+              <a:rPr sz="1150" b="1">
                 <a:solidFill>
-                  <a:srgbClr val="FFFFFF"/>
+                  <a:srgbClr val="2E74B5"/>
                 </a:solidFill>
                 <a:latin typeface="Calibri"/>
               </a:rPr>
-              <a:t>Key takeaway:  Sequential execution reaches 4-Stage 1st production ~4 months earlier (28-Jul-28 vs 27-Nov-28) and VFD 1st production ~1 week earlier (9-May-29 vs 16-May-29), avoiding the Oct-28 EC release conflict.</a:t>
+              <a:t>Scenario 1 — Sequential Execution</a:t>
+            </a:r>
+          </a:p>
+          <a:p>
+            <a:pPr>
+              <a:spcBef>
+                <a:spcPts val="200"/>
+              </a:spcBef>
+            </a:pPr>
+            <a:r>
+              <a:rPr sz="950" b="1">
+                <a:solidFill>
+                  <a:srgbClr val="262626"/>
+                </a:solidFill>
+                <a:latin typeface="Calibri"/>
+              </a:rPr>
+              <a:t>What it is:  </a:t>
+            </a:r>
+            <a:r>
+              <a:rPr sz="950">
+                <a:solidFill>
+                  <a:srgbClr val="262626"/>
+                </a:solidFill>
+                <a:latin typeface="Calibri"/>
+              </a:rPr>
+              <a:t>Finish the entire 4-Stage program first (testing → EC release → Selection Navigator → agency submission → production release), then start the VFD compressor project.</a:t>
+            </a:r>
+          </a:p>
+          <a:p>
+            <a:pPr>
+              <a:spcBef>
+                <a:spcPts val="200"/>
+              </a:spcBef>
+            </a:pPr>
+            <a:r>
+              <a:rPr sz="950" b="1">
+                <a:solidFill>
+                  <a:srgbClr val="262626"/>
+                </a:solidFill>
+                <a:latin typeface="Calibri"/>
+              </a:rPr>
+              <a:t>Challenges:  </a:t>
+            </a:r>
+            <a:r>
+              <a:rPr sz="950">
+                <a:solidFill>
+                  <a:srgbClr val="262626"/>
+                </a:solidFill>
+                <a:latin typeface="Calibri"/>
+              </a:rPr>
+              <a:t>Refrigeration team must run VFD compressor unit testing alongside the Selection Navigator &amp; UL deliverables.</a:t>
+            </a:r>
+          </a:p>
+        </p:txBody>
+      </p:sp>
+      <p:sp>
+        <p:nvSpPr>
+          <p:cNvPr id="5" name="TextBox 4"/>
+          <p:cNvSpPr txBox="1"/>
+          <p:nvPr/>
+        </p:nvSpPr>
+        <p:spPr>
+          <a:xfrm>
+            <a:off x="6153912" y="5559552"/>
+            <a:ext cx="5806440" cy="1225296"/>
+          </a:xfrm>
+          <a:prstGeom prst="rect">
+            <a:avLst/>
+          </a:prstGeom>
+          <a:solidFill>
+            <a:srgbClr val="FFFFFF"/>
+          </a:solidFill>
+          <a:ln w="9525">
+            <a:solidFill>
+              <a:srgbClr val="1E7A6F"/>
+            </a:solidFill>
+          </a:ln>
+        </p:spPr>
+        <p:txBody>
+          <a:bodyPr wrap="square" tIns="36576" bIns="36576">
+            <a:spAutoFit/>
+          </a:bodyPr>
+          <a:lstStyle/>
+          <a:p>
+            <a:r>
+              <a:rPr sz="1150" b="1">
+                <a:solidFill>
+                  <a:srgbClr val="1E7A6F"/>
+                </a:solidFill>
+                <a:latin typeface="Calibri"/>
+              </a:rPr>
+              <a:t>Scenario 2 — Parallel Execution</a:t>
+            </a:r>
+          </a:p>
+          <a:p>
+            <a:pPr>
+              <a:spcBef>
+                <a:spcPts val="200"/>
+              </a:spcBef>
+            </a:pPr>
+            <a:r>
+              <a:rPr sz="950" b="1">
+                <a:solidFill>
+                  <a:srgbClr val="262626"/>
+                </a:solidFill>
+                <a:latin typeface="Calibri"/>
+              </a:rPr>
+              <a:t>What it is:  </a:t>
+            </a:r>
+            <a:r>
+              <a:rPr sz="950">
+                <a:solidFill>
+                  <a:srgbClr val="262626"/>
+                </a:solidFill>
+                <a:latin typeface="Calibri"/>
+              </a:rPr>
+              <a:t>As each 4-Stage unit finishes testing, the same unit is converted to a VFD compressor and tested — both programs run concurrently.</a:t>
+            </a:r>
+          </a:p>
+          <a:p>
+            <a:pPr>
+              <a:spcBef>
+                <a:spcPts val="200"/>
+              </a:spcBef>
+            </a:pPr>
+            <a:r>
+              <a:rPr sz="950" b="1">
+                <a:solidFill>
+                  <a:srgbClr val="262626"/>
+                </a:solidFill>
+                <a:latin typeface="Calibri"/>
+              </a:rPr>
+              <a:t>Challenges:  </a:t>
+            </a:r>
+            <a:r>
+              <a:rPr sz="950">
+                <a:solidFill>
+                  <a:srgbClr val="262626"/>
+                </a:solidFill>
+                <a:latin typeface="Calibri"/>
+              </a:rPr>
+              <a:t>VFD/EXV firmware &amp; ultra-high-efficiency component selection needed by Nov 2026; refrigeration team can only work one project at a time; EC conflict (4-Stage MTL EC vs VFD EC release); mechanical team loaded on both projects simultaneously.</a:t>
             </a:r>
           </a:p>
         </p:txBody>

</xml_diff>